<commit_message>
0.1.0-beta.10: deck layout checks, design rules, refreshed previews
- check_deck.js renders the deck and flags text near the edges or colliding
- lint_report.js enforces per-field text length limits
- design_rules.md: design rules for templates and decks
- timeline edge overflow, hollow attention cards, small text, tracked uppercase labels fixed
- make_previews.js regenerates docs images and example decks
</commit_message>
<xml_diff>
--- a/docs/example-deck-paper.pptx
+++ b/docs/example-deck-paper.pptx
@@ -289,7 +289,7 @@
                   <c:v>2</c:v>
                 </c:pt>
                 <c:pt idx="2">
-                  <c:v>0</c:v>
+                  <c:v>1</c:v>
                 </c:pt>
               </c:numCache>
             </c:numRef>
@@ -372,7 +372,7 @@
                   <c:v>1</c:v>
                 </c:pt>
                 <c:pt idx="2">
-                  <c:v>0</c:v>
+                  <c:v>1</c:v>
                 </c:pt>
               </c:numCache>
             </c:numRef>
@@ -452,10 +452,10 @@
                   <c:v>0</c:v>
                 </c:pt>
                 <c:pt idx="1">
-                  <c:v>0</c:v>
+                  <c:v>3</c:v>
                 </c:pt>
                 <c:pt idx="2">
-                  <c:v>7</c:v>
+                  <c:v>4</c:v>
                 </c:pt>
               </c:numCache>
             </c:numRef>
@@ -2262,7 +2262,7 @@
       </p:grpSpPr>
       <p:pic>
         <p:nvPicPr>
-          <p:cNvPr id="2" name="Image 0" descr="/sessions/beautiful-vigilant-darwin/tmp/showship-deck-xNahHf/paper_cover.png">    </p:cNvPr>
+          <p:cNvPr id="2" name="Image 0" descr="/var/folders/lw/rmylcyvd5rjfxk9g1z9rrm8w0000gq/T/showship-deck-L0Xly7/paper_cover.png">    </p:cNvPr>
           <p:cNvPicPr>
             <a:picLocks noChangeAspect="1"/>
           </p:cNvPicPr>
@@ -2286,7 +2286,7 @@
       </p:pic>
       <p:pic>
         <p:nvPicPr>
-          <p:cNvPr id="3" name="Image 1" descr="/sessions/beautiful-vigilant-darwin/tmp/showship-deck-xNahHf/logo_trimmed.png">    </p:cNvPr>
+          <p:cNvPr id="3" name="Image 1" descr="/var/folders/lw/rmylcyvd5rjfxk9g1z9rrm8w0000gq/T/showship-deck-L0Xly7/logo_trimmed.png">    </p:cNvPr>
           <p:cNvPicPr>
             <a:picLocks noChangeAspect="1"/>
           </p:cNvPicPr>
@@ -2301,7 +2301,7 @@
         <p:spPr>
           <a:xfrm>
             <a:off x="640080" y="566928"/>
-            <a:ext cx="490523" cy="566928"/>
+            <a:ext cx="489642" cy="566928"/>
           </a:xfrm>
           <a:prstGeom prst="rect">
             <a:avLst/>
@@ -2332,17 +2332,6 @@
             <a:pPr indent="0" marL="0">
               <a:buNone/>
             </a:pPr>
-            <a:r>
-              <a:rPr lang="en-US" sz="1300" b="1" dirty="0">
-                <a:solidFill>
-                  <a:srgbClr val="17153A"/>
-                </a:solidFill>
-                <a:latin typeface="Poppins" pitchFamily="34" charset="0"/>
-                <a:ea typeface="Poppins" pitchFamily="34" charset="-122"/>
-                <a:cs typeface="Poppins" pitchFamily="34" charset="-120"/>
-              </a:rPr>
-              <a:t>Acme Digital Co., Ltd.</a:t>
-            </a:r>
             <a:endParaRPr lang="en-US" sz="1300" dirty="0"/>
           </a:p>
         </p:txBody>
@@ -2498,7 +2487,7 @@
               <a:buNone/>
             </a:pPr>
             <a:r>
-              <a:rPr lang="en-US" sz="1000" dirty="0">
+              <a:rPr lang="en-US" sz="1100" dirty="0">
                 <a:solidFill>
                   <a:srgbClr val="68667A"/>
                 </a:solidFill>
@@ -2508,7 +2497,7 @@
               </a:rPr>
               <a:t>Presenter</a:t>
             </a:r>
-            <a:endParaRPr lang="en-US" sz="1000" dirty="0"/>
+            <a:endParaRPr lang="en-US" sz="1100" dirty="0"/>
           </a:p>
         </p:txBody>
       </p:sp>
@@ -2576,7 +2565,7 @@
               <a:buNone/>
             </a:pPr>
             <a:r>
-              <a:rPr lang="en-US" sz="1000" dirty="0">
+              <a:rPr lang="en-US" sz="1100" dirty="0">
                 <a:solidFill>
                   <a:srgbClr val="68667A"/>
                 </a:solidFill>
@@ -2586,7 +2575,7 @@
               </a:rPr>
               <a:t>Date</a:t>
             </a:r>
-            <a:endParaRPr lang="en-US" sz="1000" dirty="0"/>
+            <a:endParaRPr lang="en-US" sz="1100" dirty="0"/>
           </a:p>
         </p:txBody>
       </p:sp>
@@ -2654,7 +2643,7 @@
               <a:buNone/>
             </a:pPr>
             <a:r>
-              <a:rPr lang="en-US" sz="950" dirty="0">
+              <a:rPr lang="en-US" sz="1100" dirty="0">
                 <a:solidFill>
                   <a:srgbClr val="68667A"/>
                 </a:solidFill>
@@ -2668,7 +2657,7 @@
               <a:buNone/>
             </a:pPr>
             <a:r>
-              <a:rPr lang="en-US" sz="950" b="1" dirty="0">
+              <a:rPr lang="en-US" sz="1100" b="1" dirty="0">
                 <a:solidFill>
                   <a:srgbClr val="17153A"/>
                 </a:solidFill>
@@ -2678,7 +2667,7 @@
               </a:rPr>
               <a:t>Showship</a:t>
             </a:r>
-            <a:endParaRPr lang="en-US" sz="950" dirty="0"/>
+            <a:endParaRPr lang="en-US" sz="1100" dirty="0"/>
           </a:p>
         </p:txBody>
       </p:sp>
@@ -2842,7 +2831,7 @@
               <a:buNone/>
             </a:pPr>
             <a:r>
-              <a:rPr lang="en-US" sz="900" dirty="0">
+              <a:rPr lang="en-US" sz="1100" dirty="0">
                 <a:solidFill>
                   <a:srgbClr val="68667A"/>
                 </a:solidFill>
@@ -2850,15 +2839,15 @@
                 <a:ea typeface="Arial" pitchFamily="34" charset="-122"/>
                 <a:cs typeface="Arial" pitchFamily="34" charset="-120"/>
               </a:rPr>
-              <a:t>Acme Digital Co., Ltd.  ·  October 9, 2026</a:t>
-            </a:r>
-            <a:endParaRPr lang="en-US" sz="900" dirty="0"/>
+              <a:t>October 9, 2026</a:t>
+            </a:r>
+            <a:endParaRPr lang="en-US" sz="1100" dirty="0"/>
           </a:p>
         </p:txBody>
       </p:sp>
       <p:pic>
         <p:nvPicPr>
-          <p:cNvPr id="6" name="Image 0" descr="/sessions/beautiful-vigilant-darwin/tmp/showship-deck-xNahHf/paper_mark.png">    </p:cNvPr>
+          <p:cNvPr id="6" name="Image 0" descr="/var/folders/lw/rmylcyvd5rjfxk9g1z9rrm8w0000gq/T/showship-deck-L0Xly7/paper_mark.png">    </p:cNvPr>
           <p:cNvPicPr>
             <a:picLocks noChangeAspect="1"/>
           </p:cNvPicPr>
@@ -2905,7 +2894,7 @@
               <a:buNone/>
             </a:pPr>
             <a:r>
-              <a:rPr lang="en-US" sz="900" dirty="0">
+              <a:rPr lang="en-US" sz="1100" dirty="0">
                 <a:solidFill>
                   <a:srgbClr val="68667A"/>
                 </a:solidFill>
@@ -2919,7 +2908,7 @@
               <a:buNone/>
             </a:pPr>
             <a:r>
-              <a:rPr lang="en-US" sz="900" b="1" dirty="0">
+              <a:rPr lang="en-US" sz="1100" b="1" dirty="0">
                 <a:solidFill>
                   <a:srgbClr val="17153A"/>
                 </a:solidFill>
@@ -2929,7 +2918,7 @@
               </a:rPr>
               <a:t>Showship</a:t>
             </a:r>
-            <a:endParaRPr lang="en-US" sz="900" dirty="0"/>
+            <a:endParaRPr lang="en-US" sz="1100" dirty="0"/>
           </a:p>
         </p:txBody>
       </p:sp>
@@ -2958,7 +2947,7 @@
               <a:buNone/>
             </a:pPr>
             <a:r>
-              <a:rPr lang="en-US" sz="900" b="1" dirty="0">
+              <a:rPr lang="en-US" sz="1100" b="1" dirty="0">
                 <a:solidFill>
                   <a:srgbClr val="17153A"/>
                 </a:solidFill>
@@ -2968,7 +2957,7 @@
               </a:rPr>
               <a:t>10</a:t>
             </a:r>
-            <a:endParaRPr lang="en-US" sz="900" dirty="0"/>
+            <a:endParaRPr lang="en-US" sz="1100" dirty="0"/>
           </a:p>
         </p:txBody>
       </p:sp>
@@ -2997,7 +2986,7 @@
               <a:buNone/>
             </a:pPr>
             <a:r>
-              <a:rPr lang="en-US" sz="1050" b="1" dirty="0">
+              <a:rPr lang="en-US" sz="1100" b="1" dirty="0">
                 <a:solidFill>
                   <a:srgbClr val="68667A"/>
                 </a:solidFill>
@@ -3007,7 +2996,7 @@
               </a:rPr>
               <a:t>Project / track</a:t>
             </a:r>
-            <a:endParaRPr lang="en-US" sz="1050" dirty="0"/>
+            <a:endParaRPr lang="en-US" sz="1100" dirty="0"/>
           </a:p>
         </p:txBody>
       </p:sp>
@@ -3036,7 +3025,7 @@
               <a:buNone/>
             </a:pPr>
             <a:r>
-              <a:rPr lang="en-US" sz="1050" b="1" dirty="0">
+              <a:rPr lang="en-US" sz="1100" b="1" dirty="0">
                 <a:solidFill>
                   <a:srgbClr val="68667A"/>
                 </a:solidFill>
@@ -3046,7 +3035,7 @@
               </a:rPr>
               <a:t>Owner</a:t>
             </a:r>
-            <a:endParaRPr lang="en-US" sz="1050" dirty="0"/>
+            <a:endParaRPr lang="en-US" sz="1100" dirty="0"/>
           </a:p>
         </p:txBody>
       </p:sp>
@@ -3075,7 +3064,7 @@
               <a:buNone/>
             </a:pPr>
             <a:r>
-              <a:rPr lang="en-US" sz="1050" b="1" dirty="0">
+              <a:rPr lang="en-US" sz="1100" b="1" dirty="0">
                 <a:solidFill>
                   <a:srgbClr val="68667A"/>
                 </a:solidFill>
@@ -3085,7 +3074,7 @@
               </a:rPr>
               <a:t>Next focus</a:t>
             </a:r>
-            <a:endParaRPr lang="en-US" sz="1050" dirty="0"/>
+            <a:endParaRPr lang="en-US" sz="1100" dirty="0"/>
           </a:p>
         </p:txBody>
       </p:sp>
@@ -3114,7 +3103,7 @@
               <a:buNone/>
             </a:pPr>
             <a:r>
-              <a:rPr lang="en-US" sz="1050" b="1" dirty="0">
+              <a:rPr lang="en-US" sz="1100" b="1" dirty="0">
                 <a:solidFill>
                   <a:srgbClr val="68667A"/>
                 </a:solidFill>
@@ -3124,7 +3113,7 @@
               </a:rPr>
               <a:t>Status</a:t>
             </a:r>
-            <a:endParaRPr lang="en-US" sz="1050" dirty="0"/>
+            <a:endParaRPr lang="en-US" sz="1100" dirty="0"/>
           </a:p>
         </p:txBody>
       </p:sp>
@@ -3324,7 +3313,7 @@
               <a:buNone/>
             </a:pPr>
             <a:r>
-              <a:rPr lang="en-US" sz="1050" b="1" dirty="0">
+              <a:rPr lang="en-US" sz="1100" b="1" dirty="0">
                 <a:solidFill>
                   <a:srgbClr val="0C7D78"/>
                 </a:solidFill>
@@ -3334,7 +3323,7 @@
               </a:rPr>
               <a:t>P3 · 40%</a:t>
             </a:r>
-            <a:endParaRPr lang="en-US" sz="1050" dirty="0"/>
+            <a:endParaRPr lang="en-US" sz="1100" dirty="0"/>
           </a:p>
         </p:txBody>
       </p:sp>
@@ -3534,7 +3523,7 @@
               <a:buNone/>
             </a:pPr>
             <a:r>
-              <a:rPr lang="en-US" sz="1050" b="1" dirty="0">
+              <a:rPr lang="en-US" sz="1100" b="1" dirty="0">
                 <a:solidFill>
                   <a:srgbClr val="0C7D78"/>
                 </a:solidFill>
@@ -3544,7 +3533,7 @@
               </a:rPr>
               <a:t>P4 · 80%</a:t>
             </a:r>
-            <a:endParaRPr lang="en-US" sz="1050" dirty="0"/>
+            <a:endParaRPr lang="en-US" sz="1100" dirty="0"/>
           </a:p>
         </p:txBody>
       </p:sp>
@@ -3744,7 +3733,7 @@
               <a:buNone/>
             </a:pPr>
             <a:r>
-              <a:rPr lang="en-US" sz="1050" b="1" dirty="0">
+              <a:rPr lang="en-US" sz="1100" b="1" dirty="0">
                 <a:solidFill>
                   <a:srgbClr val="866110"/>
                 </a:solidFill>
@@ -3754,7 +3743,7 @@
               </a:rPr>
               <a:t>In progress</a:t>
             </a:r>
-            <a:endParaRPr lang="en-US" sz="1050" dirty="0"/>
+            <a:endParaRPr lang="en-US" sz="1100" dirty="0"/>
           </a:p>
         </p:txBody>
       </p:sp>
@@ -3954,7 +3943,7 @@
               <a:buNone/>
             </a:pPr>
             <a:r>
-              <a:rPr lang="en-US" sz="1050" b="1" dirty="0">
+              <a:rPr lang="en-US" sz="1100" b="1" dirty="0">
                 <a:solidFill>
                   <a:srgbClr val="6C4CF5"/>
                 </a:solidFill>
@@ -3964,7 +3953,7 @@
               </a:rPr>
               <a:t>Done</a:t>
             </a:r>
-            <a:endParaRPr lang="en-US" sz="1050" dirty="0"/>
+            <a:endParaRPr lang="en-US" sz="1100" dirty="0"/>
           </a:p>
         </p:txBody>
       </p:sp>
@@ -4025,7 +4014,7 @@
       </p:grpSpPr>
       <p:pic>
         <p:nvPicPr>
-          <p:cNvPr id="2" name="Image 0" descr="/sessions/beautiful-vigilant-darwin/tmp/showship-deck-xNahHf/paper_cover.png">    </p:cNvPr>
+          <p:cNvPr id="2" name="Image 0" descr="/var/folders/lw/rmylcyvd5rjfxk9g1z9rrm8w0000gq/T/showship-deck-L0Xly7/paper_cover.png">    </p:cNvPr>
           <p:cNvPicPr>
             <a:picLocks noChangeAspect="1"/>
           </p:cNvPicPr>
@@ -4049,7 +4038,7 @@
       </p:pic>
       <p:pic>
         <p:nvPicPr>
-          <p:cNvPr id="3" name="Image 1" descr="/sessions/beautiful-vigilant-darwin/tmp/showship-deck-xNahHf/logo_trimmed.png">    </p:cNvPr>
+          <p:cNvPr id="3" name="Image 1" descr="/var/folders/lw/rmylcyvd5rjfxk9g1z9rrm8w0000gq/T/showship-deck-L0Xly7/logo_trimmed.png">    </p:cNvPr>
           <p:cNvPicPr>
             <a:picLocks noChangeAspect="1"/>
           </p:cNvPicPr>
@@ -4064,7 +4053,7 @@
         <p:spPr>
           <a:xfrm>
             <a:off x="640080" y="566928"/>
-            <a:ext cx="490523" cy="566928"/>
+            <a:ext cx="489642" cy="566928"/>
           </a:xfrm>
           <a:prstGeom prst="rect">
             <a:avLst/>
@@ -4095,17 +4084,6 @@
             <a:pPr indent="0" marL="0">
               <a:buNone/>
             </a:pPr>
-            <a:r>
-              <a:rPr lang="en-US" sz="1300" b="1" dirty="0">
-                <a:solidFill>
-                  <a:srgbClr val="17153A"/>
-                </a:solidFill>
-                <a:latin typeface="Poppins" pitchFamily="34" charset="0"/>
-                <a:ea typeface="Poppins" pitchFamily="34" charset="-122"/>
-                <a:cs typeface="Poppins" pitchFamily="34" charset="-120"/>
-              </a:rPr>
-              <a:t>Acme Digital Co., Ltd.</a:t>
-            </a:r>
             <a:endParaRPr lang="en-US" sz="1300" dirty="0"/>
           </a:p>
         </p:txBody>
@@ -4236,7 +4214,7 @@
               <a:buNone/>
             </a:pPr>
             <a:r>
-              <a:rPr lang="en-US" sz="1000" dirty="0">
+              <a:rPr lang="en-US" sz="1100" dirty="0">
                 <a:solidFill>
                   <a:srgbClr val="68667A"/>
                 </a:solidFill>
@@ -4246,7 +4224,7 @@
               </a:rPr>
               <a:t>Presenter</a:t>
             </a:r>
-            <a:endParaRPr lang="en-US" sz="1000" dirty="0"/>
+            <a:endParaRPr lang="en-US" sz="1100" dirty="0"/>
           </a:p>
         </p:txBody>
       </p:sp>
@@ -4314,7 +4292,7 @@
               <a:buNone/>
             </a:pPr>
             <a:r>
-              <a:rPr lang="en-US" sz="1000" dirty="0">
+              <a:rPr lang="en-US" sz="1100" dirty="0">
                 <a:solidFill>
                   <a:srgbClr val="68667A"/>
                 </a:solidFill>
@@ -4324,7 +4302,7 @@
               </a:rPr>
               <a:t>Date</a:t>
             </a:r>
-            <a:endParaRPr lang="en-US" sz="1000" dirty="0"/>
+            <a:endParaRPr lang="en-US" sz="1100" dirty="0"/>
           </a:p>
         </p:txBody>
       </p:sp>
@@ -4527,7 +4505,7 @@
               <a:buNone/>
             </a:pPr>
             <a:r>
-              <a:rPr lang="en-US" sz="900" dirty="0">
+              <a:rPr lang="en-US" sz="1100" dirty="0">
                 <a:solidFill>
                   <a:srgbClr val="68667A"/>
                 </a:solidFill>
@@ -4535,15 +4513,15 @@
                 <a:ea typeface="Arial" pitchFamily="34" charset="-122"/>
                 <a:cs typeface="Arial" pitchFamily="34" charset="-120"/>
               </a:rPr>
-              <a:t>Acme Digital Co., Ltd.  ·  October 9, 2026</a:t>
-            </a:r>
-            <a:endParaRPr lang="en-US" sz="900" dirty="0"/>
+              <a:t>October 9, 2026</a:t>
+            </a:r>
+            <a:endParaRPr lang="en-US" sz="1100" dirty="0"/>
           </a:p>
         </p:txBody>
       </p:sp>
       <p:pic>
         <p:nvPicPr>
-          <p:cNvPr id="6" name="Image 0" descr="/sessions/beautiful-vigilant-darwin/tmp/showship-deck-xNahHf/paper_mark.png">    </p:cNvPr>
+          <p:cNvPr id="6" name="Image 0" descr="/var/folders/lw/rmylcyvd5rjfxk9g1z9rrm8w0000gq/T/showship-deck-L0Xly7/paper_mark.png">    </p:cNvPr>
           <p:cNvPicPr>
             <a:picLocks noChangeAspect="1"/>
           </p:cNvPicPr>
@@ -4590,7 +4568,7 @@
               <a:buNone/>
             </a:pPr>
             <a:r>
-              <a:rPr lang="en-US" sz="900" dirty="0">
+              <a:rPr lang="en-US" sz="1100" dirty="0">
                 <a:solidFill>
                   <a:srgbClr val="68667A"/>
                 </a:solidFill>
@@ -4604,7 +4582,7 @@
               <a:buNone/>
             </a:pPr>
             <a:r>
-              <a:rPr lang="en-US" sz="900" b="1" dirty="0">
+              <a:rPr lang="en-US" sz="1100" b="1" dirty="0">
                 <a:solidFill>
                   <a:srgbClr val="17153A"/>
                 </a:solidFill>
@@ -4614,7 +4592,7 @@
               </a:rPr>
               <a:t>Showship</a:t>
             </a:r>
-            <a:endParaRPr lang="en-US" sz="900" dirty="0"/>
+            <a:endParaRPr lang="en-US" sz="1100" dirty="0"/>
           </a:p>
         </p:txBody>
       </p:sp>
@@ -4643,7 +4621,7 @@
               <a:buNone/>
             </a:pPr>
             <a:r>
-              <a:rPr lang="en-US" sz="900" b="1" dirty="0">
+              <a:rPr lang="en-US" sz="1100" b="1" dirty="0">
                 <a:solidFill>
                   <a:srgbClr val="17153A"/>
                 </a:solidFill>
@@ -4653,7 +4631,7 @@
               </a:rPr>
               <a:t>2</a:t>
             </a:r>
-            <a:endParaRPr lang="en-US" sz="900" dirty="0"/>
+            <a:endParaRPr lang="en-US" sz="1100" dirty="0"/>
           </a:p>
         </p:txBody>
       </p:sp>
@@ -4806,7 +4784,7 @@
               <a:buNone/>
             </a:pPr>
             <a:r>
-              <a:rPr lang="en-US" sz="1050" b="1" dirty="0">
+              <a:rPr lang="en-US" sz="1100" b="1" dirty="0">
                 <a:solidFill>
                   <a:srgbClr val="6C4CF5"/>
                 </a:solidFill>
@@ -4816,7 +4794,7 @@
               </a:rPr>
               <a:t>App Store Release</a:t>
             </a:r>
-            <a:endParaRPr lang="en-US" sz="1050" dirty="0"/>
+            <a:endParaRPr lang="en-US" sz="1100" dirty="0"/>
           </a:p>
         </p:txBody>
       </p:sp>
@@ -4870,7 +4848,7 @@
               <a:buNone/>
             </a:pPr>
             <a:r>
-              <a:rPr lang="en-US" sz="1050" b="1" dirty="0">
+              <a:rPr lang="en-US" sz="1100" b="1" dirty="0">
                 <a:solidFill>
                   <a:srgbClr val="6C4CF5"/>
                 </a:solidFill>
@@ -4880,7 +4858,7 @@
               </a:rPr>
               <a:t>Completed</a:t>
             </a:r>
-            <a:endParaRPr lang="en-US" sz="1050" dirty="0"/>
+            <a:endParaRPr lang="en-US" sz="1100" dirty="0"/>
           </a:p>
         </p:txBody>
       </p:sp>
@@ -5058,7 +5036,7 @@
               <a:buNone/>
             </a:pPr>
             <a:r>
-              <a:rPr lang="en-US" sz="1050" b="1" dirty="0">
+              <a:rPr lang="en-US" sz="1100" b="1" dirty="0">
                 <a:solidFill>
                   <a:srgbClr val="0C7D78"/>
                 </a:solidFill>
@@ -5068,7 +5046,7 @@
               </a:rPr>
               <a:t>ClinicBook · Patient &amp; Clinic</a:t>
             </a:r>
-            <a:endParaRPr lang="en-US" sz="1050" dirty="0"/>
+            <a:endParaRPr lang="en-US" sz="1100" dirty="0"/>
           </a:p>
         </p:txBody>
       </p:sp>
@@ -5122,7 +5100,7 @@
               <a:buNone/>
             </a:pPr>
             <a:r>
-              <a:rPr lang="en-US" sz="1050" b="1" dirty="0">
+              <a:rPr lang="en-US" sz="1100" b="1" dirty="0">
                 <a:solidFill>
                   <a:srgbClr val="0C7D78"/>
                 </a:solidFill>
@@ -5132,7 +5110,7 @@
               </a:rPr>
               <a:t>On track</a:t>
             </a:r>
-            <a:endParaRPr lang="en-US" sz="1050" dirty="0"/>
+            <a:endParaRPr lang="en-US" sz="1100" dirty="0"/>
           </a:p>
         </p:txBody>
       </p:sp>
@@ -5310,7 +5288,7 @@
               <a:buNone/>
             </a:pPr>
             <a:r>
-              <a:rPr lang="en-US" sz="1050" b="1" dirty="0">
+              <a:rPr lang="en-US" sz="1100" b="1" dirty="0">
                 <a:solidFill>
                   <a:srgbClr val="866110"/>
                 </a:solidFill>
@@ -5320,7 +5298,7 @@
               </a:rPr>
               <a:t>PulseBoard Analytics</a:t>
             </a:r>
-            <a:endParaRPr lang="en-US" sz="1050" dirty="0"/>
+            <a:endParaRPr lang="en-US" sz="1100" dirty="0"/>
           </a:p>
         </p:txBody>
       </p:sp>
@@ -5374,7 +5352,7 @@
               <a:buNone/>
             </a:pPr>
             <a:r>
-              <a:rPr lang="en-US" sz="1050" b="1" dirty="0">
+              <a:rPr lang="en-US" sz="1100" b="1" dirty="0">
                 <a:solidFill>
                   <a:srgbClr val="866110"/>
                 </a:solidFill>
@@ -5384,7 +5362,7 @@
               </a:rPr>
               <a:t>On track</a:t>
             </a:r>
-            <a:endParaRPr lang="en-US" sz="1050" dirty="0"/>
+            <a:endParaRPr lang="en-US" sz="1100" dirty="0"/>
           </a:p>
         </p:txBody>
       </p:sp>
@@ -5467,7 +5445,7 @@
                 <a:ea typeface="Arial" pitchFamily="34" charset="-122"/>
                 <a:cs typeface="Arial" pitchFamily="34" charset="-120"/>
               </a:rPr>
-              <a:t>Data transfer finished; usage tracking is being rolled out.</a:t>
+              <a:t>Data transfer to the new system finished; usage tracking is being rolled out.</a:t>
             </a:r>
             <a:endParaRPr lang="en-US" sz="1150" dirty="0"/>
           </a:p>
@@ -5633,7 +5611,7 @@
               <a:buNone/>
             </a:pPr>
             <a:r>
-              <a:rPr lang="en-US" sz="900" dirty="0">
+              <a:rPr lang="en-US" sz="1100" dirty="0">
                 <a:solidFill>
                   <a:srgbClr val="68667A"/>
                 </a:solidFill>
@@ -5641,15 +5619,15 @@
                 <a:ea typeface="Arial" pitchFamily="34" charset="-122"/>
                 <a:cs typeface="Arial" pitchFamily="34" charset="-120"/>
               </a:rPr>
-              <a:t>Acme Digital Co., Ltd.  ·  October 9, 2026</a:t>
-            </a:r>
-            <a:endParaRPr lang="en-US" sz="900" dirty="0"/>
+              <a:t>October 9, 2026</a:t>
+            </a:r>
+            <a:endParaRPr lang="en-US" sz="1100" dirty="0"/>
           </a:p>
         </p:txBody>
       </p:sp>
       <p:pic>
         <p:nvPicPr>
-          <p:cNvPr id="6" name="Image 0" descr="/sessions/beautiful-vigilant-darwin/tmp/showship-deck-xNahHf/paper_mark.png">    </p:cNvPr>
+          <p:cNvPr id="6" name="Image 0" descr="/var/folders/lw/rmylcyvd5rjfxk9g1z9rrm8w0000gq/T/showship-deck-L0Xly7/paper_mark.png">    </p:cNvPr>
           <p:cNvPicPr>
             <a:picLocks noChangeAspect="1"/>
           </p:cNvPicPr>
@@ -5696,7 +5674,7 @@
               <a:buNone/>
             </a:pPr>
             <a:r>
-              <a:rPr lang="en-US" sz="900" dirty="0">
+              <a:rPr lang="en-US" sz="1100" dirty="0">
                 <a:solidFill>
                   <a:srgbClr val="68667A"/>
                 </a:solidFill>
@@ -5710,7 +5688,7 @@
               <a:buNone/>
             </a:pPr>
             <a:r>
-              <a:rPr lang="en-US" sz="900" b="1" dirty="0">
+              <a:rPr lang="en-US" sz="1100" b="1" dirty="0">
                 <a:solidFill>
                   <a:srgbClr val="17153A"/>
                 </a:solidFill>
@@ -5720,7 +5698,7 @@
               </a:rPr>
               <a:t>Showship</a:t>
             </a:r>
-            <a:endParaRPr lang="en-US" sz="900" dirty="0"/>
+            <a:endParaRPr lang="en-US" sz="1100" dirty="0"/>
           </a:p>
         </p:txBody>
       </p:sp>
@@ -5749,7 +5727,7 @@
               <a:buNone/>
             </a:pPr>
             <a:r>
-              <a:rPr lang="en-US" sz="900" b="1" dirty="0">
+              <a:rPr lang="en-US" sz="1100" b="1" dirty="0">
                 <a:solidFill>
                   <a:srgbClr val="17153A"/>
                 </a:solidFill>
@@ -5759,7 +5737,7 @@
               </a:rPr>
               <a:t>3</a:t>
             </a:r>
-            <a:endParaRPr lang="en-US" sz="900" dirty="0"/>
+            <a:endParaRPr lang="en-US" sz="1100" dirty="0"/>
           </a:p>
         </p:txBody>
       </p:sp>
@@ -5813,7 +5791,7 @@
               <a:buNone/>
             </a:pPr>
             <a:r>
-              <a:rPr lang="en-US" sz="1050" b="1" dirty="0">
+              <a:rPr lang="en-US" sz="1100" b="1" dirty="0">
                 <a:solidFill>
                   <a:srgbClr val="6C4CF5"/>
                 </a:solidFill>
@@ -5823,7 +5801,7 @@
               </a:rPr>
               <a:t>Blocker resolved</a:t>
             </a:r>
-            <a:endParaRPr lang="en-US" sz="1050" dirty="0"/>
+            <a:endParaRPr lang="en-US" sz="1100" dirty="0"/>
           </a:p>
         </p:txBody>
       </p:sp>
@@ -5873,7 +5851,7 @@
       </p:sp>
       <p:pic>
         <p:nvPicPr>
-          <p:cNvPr id="12" name="Image 1" descr="/sessions/beautiful-vigilant-darwin/tmp/showship-deck-xNahHf/paper_tl_1.png">    </p:cNvPr>
+          <p:cNvPr id="12" name="Image 1" descr="/var/folders/lw/rmylcyvd5rjfxk9g1z9rrm8w0000gq/T/showship-deck-L0Xly7/paper_tl_1.png">    </p:cNvPr>
           <p:cNvPicPr>
             <a:picLocks noChangeAspect="1"/>
           </p:cNvPicPr>
@@ -5945,7 +5923,7 @@
               <a:buNone/>
             </a:pPr>
             <a:r>
-              <a:rPr lang="en-US" sz="1000" b="1" dirty="0">
+              <a:rPr lang="en-US" sz="1100" b="1" dirty="0">
                 <a:solidFill>
                   <a:srgbClr val="C34027"/>
                 </a:solidFill>
@@ -5955,7 +5933,7 @@
               </a:rPr>
               <a:t>Last week</a:t>
             </a:r>
-            <a:endParaRPr lang="en-US" sz="1000" dirty="0"/>
+            <a:endParaRPr lang="en-US" sz="1100" dirty="0"/>
           </a:p>
         </p:txBody>
       </p:sp>
@@ -6094,7 +6072,7 @@
               <a:buNone/>
             </a:pPr>
             <a:r>
-              <a:rPr lang="en-US" sz="1000" b="1" dirty="0">
+              <a:rPr lang="en-US" sz="1100" b="1" dirty="0">
                 <a:solidFill>
                   <a:srgbClr val="68667A"/>
                 </a:solidFill>
@@ -6104,7 +6082,7 @@
               </a:rPr>
               <a:t>This week</a:t>
             </a:r>
-            <a:endParaRPr lang="en-US" sz="1000" dirty="0"/>
+            <a:endParaRPr lang="en-US" sz="1100" dirty="0"/>
           </a:p>
         </p:txBody>
       </p:sp>
@@ -6243,7 +6221,7 @@
               <a:buNone/>
             </a:pPr>
             <a:r>
-              <a:rPr lang="en-US" sz="1000" b="1" dirty="0">
+              <a:rPr lang="en-US" sz="1100" b="1" dirty="0">
                 <a:solidFill>
                   <a:srgbClr val="68667A"/>
                 </a:solidFill>
@@ -6253,7 +6231,7 @@
               </a:rPr>
               <a:t>This week</a:t>
             </a:r>
-            <a:endParaRPr lang="en-US" sz="1000" dirty="0"/>
+            <a:endParaRPr lang="en-US" sz="1100" dirty="0"/>
           </a:p>
         </p:txBody>
       </p:sp>
@@ -6392,7 +6370,7 @@
               <a:buNone/>
             </a:pPr>
             <a:r>
-              <a:rPr lang="en-US" sz="1000" b="1" dirty="0">
+              <a:rPr lang="en-US" sz="1100" b="1" dirty="0">
                 <a:solidFill>
                   <a:srgbClr val="68667A"/>
                 </a:solidFill>
@@ -6402,7 +6380,7 @@
               </a:rPr>
               <a:t>This week</a:t>
             </a:r>
-            <a:endParaRPr lang="en-US" sz="1000" dirty="0"/>
+            <a:endParaRPr lang="en-US" sz="1100" dirty="0"/>
           </a:p>
         </p:txBody>
       </p:sp>
@@ -6651,7 +6629,7 @@
               <a:buNone/>
             </a:pPr>
             <a:r>
-              <a:rPr lang="en-US" sz="900" dirty="0">
+              <a:rPr lang="en-US" sz="1100" dirty="0">
                 <a:solidFill>
                   <a:srgbClr val="68667A"/>
                 </a:solidFill>
@@ -6659,15 +6637,15 @@
                 <a:ea typeface="Arial" pitchFamily="34" charset="-122"/>
                 <a:cs typeface="Arial" pitchFamily="34" charset="-120"/>
               </a:rPr>
-              <a:t>Acme Digital Co., Ltd.  ·  October 9, 2026</a:t>
-            </a:r>
-            <a:endParaRPr lang="en-US" sz="900" dirty="0"/>
+              <a:t>October 9, 2026</a:t>
+            </a:r>
+            <a:endParaRPr lang="en-US" sz="1100" dirty="0"/>
           </a:p>
         </p:txBody>
       </p:sp>
       <p:pic>
         <p:nvPicPr>
-          <p:cNvPr id="6" name="Image 0" descr="/sessions/beautiful-vigilant-darwin/tmp/showship-deck-xNahHf/paper_mark.png">    </p:cNvPr>
+          <p:cNvPr id="6" name="Image 0" descr="/var/folders/lw/rmylcyvd5rjfxk9g1z9rrm8w0000gq/T/showship-deck-L0Xly7/paper_mark.png">    </p:cNvPr>
           <p:cNvPicPr>
             <a:picLocks noChangeAspect="1"/>
           </p:cNvPicPr>
@@ -6714,7 +6692,7 @@
               <a:buNone/>
             </a:pPr>
             <a:r>
-              <a:rPr lang="en-US" sz="900" dirty="0">
+              <a:rPr lang="en-US" sz="1100" dirty="0">
                 <a:solidFill>
                   <a:srgbClr val="68667A"/>
                 </a:solidFill>
@@ -6728,7 +6706,7 @@
               <a:buNone/>
             </a:pPr>
             <a:r>
-              <a:rPr lang="en-US" sz="900" b="1" dirty="0">
+              <a:rPr lang="en-US" sz="1100" b="1" dirty="0">
                 <a:solidFill>
                   <a:srgbClr val="17153A"/>
                 </a:solidFill>
@@ -6738,7 +6716,7 @@
               </a:rPr>
               <a:t>Showship</a:t>
             </a:r>
-            <a:endParaRPr lang="en-US" sz="900" dirty="0"/>
+            <a:endParaRPr lang="en-US" sz="1100" dirty="0"/>
           </a:p>
         </p:txBody>
       </p:sp>
@@ -6767,7 +6745,7 @@
               <a:buNone/>
             </a:pPr>
             <a:r>
-              <a:rPr lang="en-US" sz="900" b="1" dirty="0">
+              <a:rPr lang="en-US" sz="1100" b="1" dirty="0">
                 <a:solidFill>
                   <a:srgbClr val="17153A"/>
                 </a:solidFill>
@@ -6777,7 +6755,7 @@
               </a:rPr>
               <a:t>4</a:t>
             </a:r>
-            <a:endParaRPr lang="en-US" sz="900" dirty="0"/>
+            <a:endParaRPr lang="en-US" sz="1100" dirty="0"/>
           </a:p>
         </p:txBody>
       </p:sp>
@@ -6971,7 +6949,7 @@
               <a:buNone/>
             </a:pPr>
             <a:r>
-              <a:rPr lang="en-US" sz="1050" b="1" dirty="0">
+              <a:rPr lang="en-US" sz="1100" b="1" dirty="0">
                 <a:solidFill>
                   <a:srgbClr val="68667A"/>
                 </a:solidFill>
@@ -6981,7 +6959,7 @@
               </a:rPr>
               <a:t>Track</a:t>
             </a:r>
-            <a:endParaRPr lang="en-US" sz="1050" dirty="0"/>
+            <a:endParaRPr lang="en-US" sz="1100" dirty="0"/>
           </a:p>
         </p:txBody>
       </p:sp>
@@ -7010,7 +6988,7 @@
               <a:buNone/>
             </a:pPr>
             <a:r>
-              <a:rPr lang="en-US" sz="1050" b="1" dirty="0">
+              <a:rPr lang="en-US" sz="1100" b="1" dirty="0">
                 <a:solidFill>
                   <a:srgbClr val="68667A"/>
                 </a:solidFill>
@@ -7020,7 +6998,7 @@
               </a:rPr>
               <a:t>Progress</a:t>
             </a:r>
-            <a:endParaRPr lang="en-US" sz="1050" dirty="0"/>
+            <a:endParaRPr lang="en-US" sz="1100" dirty="0"/>
           </a:p>
         </p:txBody>
       </p:sp>
@@ -7111,7 +7089,7 @@
               <a:buNone/>
             </a:pPr>
             <a:r>
-              <a:rPr lang="en-US" sz="1050" dirty="0">
+              <a:rPr lang="en-US" sz="1100" dirty="0">
                 <a:solidFill>
                   <a:srgbClr val="68667A"/>
                 </a:solidFill>
@@ -7121,7 +7099,7 @@
               </a:rPr>
               <a:t>Owner: Leo Park @Leo</a:t>
             </a:r>
-            <a:endParaRPr lang="en-US" sz="1050" dirty="0"/>
+            <a:endParaRPr lang="en-US" sz="1100" dirty="0"/>
           </a:p>
         </p:txBody>
       </p:sp>
@@ -7291,7 +7269,7 @@
               <a:buNone/>
             </a:pPr>
             <a:r>
-              <a:rPr lang="en-US" sz="1050" dirty="0">
+              <a:rPr lang="en-US" sz="1100" dirty="0">
                 <a:solidFill>
                   <a:srgbClr val="68667A"/>
                 </a:solidFill>
@@ -7301,7 +7279,7 @@
               </a:rPr>
               <a:t>Owner: Nina Rao @Nina</a:t>
             </a:r>
-            <a:endParaRPr lang="en-US" sz="1050" dirty="0"/>
+            <a:endParaRPr lang="en-US" sz="1100" dirty="0"/>
           </a:p>
         </p:txBody>
       </p:sp>
@@ -7613,7 +7591,7 @@
               <a:buNone/>
             </a:pPr>
             <a:r>
-              <a:rPr lang="en-US" sz="1000" i="1" dirty="0">
+              <a:rPr lang="en-US" sz="1100" i="1" dirty="0">
                 <a:solidFill>
                   <a:srgbClr val="68667A"/>
                 </a:solidFill>
@@ -7623,7 +7601,7 @@
               </a:rPr>
               <a:t>Progress = average completion of each track's four phases.</a:t>
             </a:r>
-            <a:endParaRPr lang="en-US" sz="1000" dirty="0"/>
+            <a:endParaRPr lang="en-US" sz="1100" dirty="0"/>
           </a:p>
         </p:txBody>
       </p:sp>
@@ -7787,7 +7765,7 @@
               <a:buNone/>
             </a:pPr>
             <a:r>
-              <a:rPr lang="en-US" sz="900" dirty="0">
+              <a:rPr lang="en-US" sz="1100" dirty="0">
                 <a:solidFill>
                   <a:srgbClr val="68667A"/>
                 </a:solidFill>
@@ -7795,15 +7773,15 @@
                 <a:ea typeface="Arial" pitchFamily="34" charset="-122"/>
                 <a:cs typeface="Arial" pitchFamily="34" charset="-120"/>
               </a:rPr>
-              <a:t>Acme Digital Co., Ltd.  ·  October 9, 2026</a:t>
-            </a:r>
-            <a:endParaRPr lang="en-US" sz="900" dirty="0"/>
+              <a:t>October 9, 2026</a:t>
+            </a:r>
+            <a:endParaRPr lang="en-US" sz="1100" dirty="0"/>
           </a:p>
         </p:txBody>
       </p:sp>
       <p:pic>
         <p:nvPicPr>
-          <p:cNvPr id="6" name="Image 0" descr="/sessions/beautiful-vigilant-darwin/tmp/showship-deck-xNahHf/paper_mark.png">    </p:cNvPr>
+          <p:cNvPr id="6" name="Image 0" descr="/var/folders/lw/rmylcyvd5rjfxk9g1z9rrm8w0000gq/T/showship-deck-L0Xly7/paper_mark.png">    </p:cNvPr>
           <p:cNvPicPr>
             <a:picLocks noChangeAspect="1"/>
           </p:cNvPicPr>
@@ -7850,7 +7828,7 @@
               <a:buNone/>
             </a:pPr>
             <a:r>
-              <a:rPr lang="en-US" sz="900" dirty="0">
+              <a:rPr lang="en-US" sz="1100" dirty="0">
                 <a:solidFill>
                   <a:srgbClr val="68667A"/>
                 </a:solidFill>
@@ -7864,7 +7842,7 @@
               <a:buNone/>
             </a:pPr>
             <a:r>
-              <a:rPr lang="en-US" sz="900" b="1" dirty="0">
+              <a:rPr lang="en-US" sz="1100" b="1" dirty="0">
                 <a:solidFill>
                   <a:srgbClr val="17153A"/>
                 </a:solidFill>
@@ -7874,7 +7852,7 @@
               </a:rPr>
               <a:t>Showship</a:t>
             </a:r>
-            <a:endParaRPr lang="en-US" sz="900" dirty="0"/>
+            <a:endParaRPr lang="en-US" sz="1100" dirty="0"/>
           </a:p>
         </p:txBody>
       </p:sp>
@@ -7903,7 +7881,7 @@
               <a:buNone/>
             </a:pPr>
             <a:r>
-              <a:rPr lang="en-US" sz="900" b="1" dirty="0">
+              <a:rPr lang="en-US" sz="1100" b="1" dirty="0">
                 <a:solidFill>
                   <a:srgbClr val="17153A"/>
                 </a:solidFill>
@@ -7913,7 +7891,7 @@
               </a:rPr>
               <a:t>5</a:t>
             </a:r>
-            <a:endParaRPr lang="en-US" sz="900" dirty="0"/>
+            <a:endParaRPr lang="en-US" sz="1100" dirty="0"/>
           </a:p>
         </p:txBody>
       </p:sp>
@@ -9360,7 +9338,7 @@
               <a:buNone/>
             </a:pPr>
             <a:r>
-              <a:rPr lang="en-US" sz="900" dirty="0">
+              <a:rPr lang="en-US" sz="1100" dirty="0">
                 <a:solidFill>
                   <a:srgbClr val="68667A"/>
                 </a:solidFill>
@@ -9368,15 +9346,15 @@
                 <a:ea typeface="Arial" pitchFamily="34" charset="-122"/>
                 <a:cs typeface="Arial" pitchFamily="34" charset="-120"/>
               </a:rPr>
-              <a:t>Acme Digital Co., Ltd.  ·  October 9, 2026</a:t>
-            </a:r>
-            <a:endParaRPr lang="en-US" sz="900" dirty="0"/>
+              <a:t>October 9, 2026</a:t>
+            </a:r>
+            <a:endParaRPr lang="en-US" sz="1100" dirty="0"/>
           </a:p>
         </p:txBody>
       </p:sp>
       <p:pic>
         <p:nvPicPr>
-          <p:cNvPr id="6" name="Image 0" descr="/sessions/beautiful-vigilant-darwin/tmp/showship-deck-xNahHf/paper_mark.png">    </p:cNvPr>
+          <p:cNvPr id="6" name="Image 0" descr="/var/folders/lw/rmylcyvd5rjfxk9g1z9rrm8w0000gq/T/showship-deck-L0Xly7/paper_mark.png">    </p:cNvPr>
           <p:cNvPicPr>
             <a:picLocks noChangeAspect="1"/>
           </p:cNvPicPr>
@@ -9423,7 +9401,7 @@
               <a:buNone/>
             </a:pPr>
             <a:r>
-              <a:rPr lang="en-US" sz="900" dirty="0">
+              <a:rPr lang="en-US" sz="1100" dirty="0">
                 <a:solidFill>
                   <a:srgbClr val="68667A"/>
                 </a:solidFill>
@@ -9437,7 +9415,7 @@
               <a:buNone/>
             </a:pPr>
             <a:r>
-              <a:rPr lang="en-US" sz="900" b="1" dirty="0">
+              <a:rPr lang="en-US" sz="1100" b="1" dirty="0">
                 <a:solidFill>
                   <a:srgbClr val="17153A"/>
                 </a:solidFill>
@@ -9447,7 +9425,7 @@
               </a:rPr>
               <a:t>Showship</a:t>
             </a:r>
-            <a:endParaRPr lang="en-US" sz="900" dirty="0"/>
+            <a:endParaRPr lang="en-US" sz="1100" dirty="0"/>
           </a:p>
         </p:txBody>
       </p:sp>
@@ -9476,7 +9454,7 @@
               <a:buNone/>
             </a:pPr>
             <a:r>
-              <a:rPr lang="en-US" sz="900" b="1" dirty="0">
+              <a:rPr lang="en-US" sz="1100" b="1" dirty="0">
                 <a:solidFill>
                   <a:srgbClr val="17153A"/>
                 </a:solidFill>
@@ -9486,7 +9464,7 @@
               </a:rPr>
               <a:t>6</a:t>
             </a:r>
-            <a:endParaRPr lang="en-US" sz="900" dirty="0"/>
+            <a:endParaRPr lang="en-US" sz="1100" dirty="0"/>
           </a:p>
         </p:txBody>
       </p:sp>
@@ -9880,7 +9858,7 @@
               <a:buNone/>
             </a:pPr>
             <a:r>
-              <a:rPr lang="en-US" sz="1050" b="1" dirty="0">
+              <a:rPr lang="en-US" sz="1100" b="1" dirty="0">
                 <a:solidFill>
                   <a:srgbClr val="6C4CF5"/>
                 </a:solidFill>
@@ -9890,7 +9868,7 @@
               </a:rPr>
               <a:t>Verified</a:t>
             </a:r>
-            <a:endParaRPr lang="en-US" sz="1050" dirty="0"/>
+            <a:endParaRPr lang="en-US" sz="1100" dirty="0"/>
           </a:p>
         </p:txBody>
       </p:sp>
@@ -10050,7 +10028,7 @@
               <a:buNone/>
             </a:pPr>
             <a:r>
-              <a:rPr lang="en-US" sz="1050" b="1" dirty="0">
+              <a:rPr lang="en-US" sz="1100" b="1" dirty="0">
                 <a:solidFill>
                   <a:srgbClr val="6C4CF5"/>
                 </a:solidFill>
@@ -10060,7 +10038,7 @@
               </a:rPr>
               <a:t>Fix before release</a:t>
             </a:r>
-            <a:endParaRPr lang="en-US" sz="1050" dirty="0"/>
+            <a:endParaRPr lang="en-US" sz="1100" dirty="0"/>
           </a:p>
         </p:txBody>
       </p:sp>
@@ -10220,7 +10198,7 @@
               <a:buNone/>
             </a:pPr>
             <a:r>
-              <a:rPr lang="en-US" sz="1050" b="1" dirty="0">
+              <a:rPr lang="en-US" sz="1100" b="1" dirty="0">
                 <a:solidFill>
                   <a:srgbClr val="6C4CF5"/>
                 </a:solidFill>
@@ -10230,7 +10208,7 @@
               </a:rPr>
               <a:t>Verified</a:t>
             </a:r>
-            <a:endParaRPr lang="en-US" sz="1050" dirty="0"/>
+            <a:endParaRPr lang="en-US" sz="1100" dirty="0"/>
           </a:p>
         </p:txBody>
       </p:sp>
@@ -10259,7 +10237,7 @@
               <a:buNone/>
             </a:pPr>
             <a:r>
-              <a:rPr lang="en-US" sz="1000" i="1" dirty="0">
+              <a:rPr lang="en-US" sz="1100" i="1" dirty="0">
                 <a:solidFill>
                   <a:srgbClr val="68667A"/>
                 </a:solidFill>
@@ -10269,7 +10247,7 @@
               </a:rPr>
               <a:t>Source: lead's code reviews this week.</a:t>
             </a:r>
-            <a:endParaRPr lang="en-US" sz="1000" dirty="0"/>
+            <a:endParaRPr lang="en-US" sz="1100" dirty="0"/>
           </a:p>
         </p:txBody>
       </p:sp>
@@ -10433,7 +10411,7 @@
               <a:buNone/>
             </a:pPr>
             <a:r>
-              <a:rPr lang="en-US" sz="900" dirty="0">
+              <a:rPr lang="en-US" sz="1100" dirty="0">
                 <a:solidFill>
                   <a:srgbClr val="68667A"/>
                 </a:solidFill>
@@ -10441,15 +10419,15 @@
                 <a:ea typeface="Arial" pitchFamily="34" charset="-122"/>
                 <a:cs typeface="Arial" pitchFamily="34" charset="-120"/>
               </a:rPr>
-              <a:t>Acme Digital Co., Ltd.  ·  October 9, 2026</a:t>
-            </a:r>
-            <a:endParaRPr lang="en-US" sz="900" dirty="0"/>
+              <a:t>October 9, 2026</a:t>
+            </a:r>
+            <a:endParaRPr lang="en-US" sz="1100" dirty="0"/>
           </a:p>
         </p:txBody>
       </p:sp>
       <p:pic>
         <p:nvPicPr>
-          <p:cNvPr id="6" name="Image 0" descr="/sessions/beautiful-vigilant-darwin/tmp/showship-deck-xNahHf/paper_mark.png">    </p:cNvPr>
+          <p:cNvPr id="6" name="Image 0" descr="/var/folders/lw/rmylcyvd5rjfxk9g1z9rrm8w0000gq/T/showship-deck-L0Xly7/paper_mark.png">    </p:cNvPr>
           <p:cNvPicPr>
             <a:picLocks noChangeAspect="1"/>
           </p:cNvPicPr>
@@ -10496,7 +10474,7 @@
               <a:buNone/>
             </a:pPr>
             <a:r>
-              <a:rPr lang="en-US" sz="900" dirty="0">
+              <a:rPr lang="en-US" sz="1100" dirty="0">
                 <a:solidFill>
                   <a:srgbClr val="68667A"/>
                 </a:solidFill>
@@ -10510,7 +10488,7 @@
               <a:buNone/>
             </a:pPr>
             <a:r>
-              <a:rPr lang="en-US" sz="900" b="1" dirty="0">
+              <a:rPr lang="en-US" sz="1100" b="1" dirty="0">
                 <a:solidFill>
                   <a:srgbClr val="17153A"/>
                 </a:solidFill>
@@ -10520,7 +10498,7 @@
               </a:rPr>
               <a:t>Showship</a:t>
             </a:r>
-            <a:endParaRPr lang="en-US" sz="900" dirty="0"/>
+            <a:endParaRPr lang="en-US" sz="1100" dirty="0"/>
           </a:p>
         </p:txBody>
       </p:sp>
@@ -10549,7 +10527,7 @@
               <a:buNone/>
             </a:pPr>
             <a:r>
-              <a:rPr lang="en-US" sz="900" b="1" dirty="0">
+              <a:rPr lang="en-US" sz="1100" b="1" dirty="0">
                 <a:solidFill>
                   <a:srgbClr val="17153A"/>
                 </a:solidFill>
@@ -10559,7 +10537,7 @@
               </a:rPr>
               <a:t>7</a:t>
             </a:r>
-            <a:endParaRPr lang="en-US" sz="900" dirty="0"/>
+            <a:endParaRPr lang="en-US" sz="1100" dirty="0"/>
           </a:p>
         </p:txBody>
       </p:sp>
@@ -10757,7 +10735,7 @@
               <a:buNone/>
             </a:pPr>
             <a:r>
-              <a:rPr lang="en-US" sz="1050" i="1" dirty="0">
+              <a:rPr lang="en-US" sz="1100" i="1" dirty="0">
                 <a:solidFill>
                   <a:srgbClr val="68667A"/>
                 </a:solidFill>
@@ -10965,7 +10943,7 @@
               <a:buNone/>
             </a:pPr>
             <a:r>
-              <a:rPr lang="en-US" sz="1050" i="1" dirty="0">
+              <a:rPr lang="en-US" sz="1100" i="1" dirty="0">
                 <a:solidFill>
                   <a:srgbClr val="68667A"/>
                 </a:solidFill>
@@ -11139,7 +11117,7 @@
               <a:buNone/>
             </a:pPr>
             <a:r>
-              <a:rPr lang="en-US" sz="900" dirty="0">
+              <a:rPr lang="en-US" sz="1100" dirty="0">
                 <a:solidFill>
                   <a:srgbClr val="68667A"/>
                 </a:solidFill>
@@ -11147,15 +11125,15 @@
                 <a:ea typeface="Arial" pitchFamily="34" charset="-122"/>
                 <a:cs typeface="Arial" pitchFamily="34" charset="-120"/>
               </a:rPr>
-              <a:t>Acme Digital Co., Ltd.  ·  October 9, 2026</a:t>
-            </a:r>
-            <a:endParaRPr lang="en-US" sz="900" dirty="0"/>
+              <a:t>October 9, 2026</a:t>
+            </a:r>
+            <a:endParaRPr lang="en-US" sz="1100" dirty="0"/>
           </a:p>
         </p:txBody>
       </p:sp>
       <p:pic>
         <p:nvPicPr>
-          <p:cNvPr id="6" name="Image 0" descr="/sessions/beautiful-vigilant-darwin/tmp/showship-deck-xNahHf/paper_mark.png">    </p:cNvPr>
+          <p:cNvPr id="6" name="Image 0" descr="/var/folders/lw/rmylcyvd5rjfxk9g1z9rrm8w0000gq/T/showship-deck-L0Xly7/paper_mark.png">    </p:cNvPr>
           <p:cNvPicPr>
             <a:picLocks noChangeAspect="1"/>
           </p:cNvPicPr>
@@ -11202,7 +11180,7 @@
               <a:buNone/>
             </a:pPr>
             <a:r>
-              <a:rPr lang="en-US" sz="900" dirty="0">
+              <a:rPr lang="en-US" sz="1100" dirty="0">
                 <a:solidFill>
                   <a:srgbClr val="68667A"/>
                 </a:solidFill>
@@ -11216,7 +11194,7 @@
               <a:buNone/>
             </a:pPr>
             <a:r>
-              <a:rPr lang="en-US" sz="900" b="1" dirty="0">
+              <a:rPr lang="en-US" sz="1100" b="1" dirty="0">
                 <a:solidFill>
                   <a:srgbClr val="17153A"/>
                 </a:solidFill>
@@ -11226,7 +11204,7 @@
               </a:rPr>
               <a:t>Showship</a:t>
             </a:r>
-            <a:endParaRPr lang="en-US" sz="900" dirty="0"/>
+            <a:endParaRPr lang="en-US" sz="1100" dirty="0"/>
           </a:p>
         </p:txBody>
       </p:sp>
@@ -11255,7 +11233,7 @@
               <a:buNone/>
             </a:pPr>
             <a:r>
-              <a:rPr lang="en-US" sz="900" b="1" dirty="0">
+              <a:rPr lang="en-US" sz="1100" b="1" dirty="0">
                 <a:solidFill>
                   <a:srgbClr val="17153A"/>
                 </a:solidFill>
@@ -11265,7 +11243,7 @@
               </a:rPr>
               <a:t>8</a:t>
             </a:r>
-            <a:endParaRPr lang="en-US" sz="900" dirty="0"/>
+            <a:endParaRPr lang="en-US" sz="1100" dirty="0"/>
           </a:p>
         </p:txBody>
       </p:sp>
@@ -11337,7 +11315,7 @@
               <a:buNone/>
             </a:pPr>
             <a:r>
-              <a:rPr lang="en-US" sz="1050" b="1" dirty="0">
+              <a:rPr lang="en-US" sz="1100" b="1" dirty="0">
                 <a:solidFill>
                   <a:srgbClr val="0C7D78"/>
                 </a:solidFill>
@@ -11347,7 +11325,7 @@
               </a:rPr>
               <a:t>ClinicBook · Patient App</a:t>
             </a:r>
-            <a:endParaRPr lang="en-US" sz="1050" dirty="0"/>
+            <a:endParaRPr lang="en-US" sz="1100" dirty="0"/>
           </a:p>
         </p:txBody>
       </p:sp>
@@ -11378,7 +11356,7 @@
               <a:buNone/>
             </a:pPr>
             <a:r>
-              <a:rPr lang="en-US" sz="1050" i="1" dirty="0">
+              <a:rPr lang="en-US" sz="1100" i="1" dirty="0">
                 <a:solidFill>
                   <a:srgbClr val="48465C"/>
                 </a:solidFill>
@@ -11388,7 +11366,7 @@
               </a:rPr>
               <a:t>Sign-in and clinic search done; booking calendar in progress.</a:t>
             </a:r>
-            <a:endParaRPr lang="en-US" sz="1050" dirty="0"/>
+            <a:endParaRPr lang="en-US" sz="1100" dirty="0"/>
           </a:p>
         </p:txBody>
       </p:sp>
@@ -11542,7 +11520,7 @@
               <a:buNone/>
             </a:pPr>
             <a:r>
-              <a:rPr lang="en-US" sz="1050" dirty="0">
+              <a:rPr lang="en-US" sz="1100" dirty="0">
                 <a:solidFill>
                   <a:srgbClr val="48465C"/>
                 </a:solidFill>
@@ -11552,7 +11530,7 @@
               </a:rPr>
               <a:t>3 done, 2 open</a:t>
             </a:r>
-            <a:endParaRPr lang="en-US" sz="1050" dirty="0"/>
+            <a:endParaRPr lang="en-US" sz="1100" dirty="0"/>
           </a:p>
         </p:txBody>
       </p:sp>
@@ -11687,7 +11665,7 @@
               <a:buNone/>
             </a:pPr>
             <a:r>
-              <a:rPr lang="en-US" sz="1050" dirty="0">
+              <a:rPr lang="en-US" sz="1100" dirty="0">
                 <a:solidFill>
                   <a:srgbClr val="17153A"/>
                 </a:solidFill>
@@ -11697,7 +11675,7 @@
               </a:rPr>
               <a:t>P1 · Accounts &amp; Sign-in (3/3)</a:t>
             </a:r>
-            <a:endParaRPr lang="en-US" sz="1050" dirty="0"/>
+            <a:endParaRPr lang="en-US" sz="1100" dirty="0"/>
           </a:p>
         </p:txBody>
       </p:sp>
@@ -11753,7 +11731,7 @@
               <a:buNone/>
             </a:pPr>
             <a:r>
-              <a:rPr lang="en-US" sz="1050" dirty="0">
+              <a:rPr lang="en-US" sz="1100" dirty="0">
                 <a:solidFill>
                   <a:srgbClr val="17153A"/>
                 </a:solidFill>
@@ -11763,7 +11741,7 @@
               </a:rPr>
               <a:t>P2 · Clinic Search &amp; Maps (5/5)</a:t>
             </a:r>
-            <a:endParaRPr lang="en-US" sz="1050" dirty="0"/>
+            <a:endParaRPr lang="en-US" sz="1100" dirty="0"/>
           </a:p>
         </p:txBody>
       </p:sp>
@@ -11819,7 +11797,7 @@
               <a:buNone/>
             </a:pPr>
             <a:r>
-              <a:rPr lang="en-US" sz="1050" dirty="0">
+              <a:rPr lang="en-US" sz="1100" dirty="0">
                 <a:solidFill>
                   <a:srgbClr val="17153A"/>
                 </a:solidFill>
@@ -11829,7 +11807,7 @@
               </a:rPr>
               <a:t>P3 · Booking Calendar (2/5)</a:t>
             </a:r>
-            <a:endParaRPr lang="en-US" sz="1050" dirty="0"/>
+            <a:endParaRPr lang="en-US" sz="1100" dirty="0"/>
           </a:p>
         </p:txBody>
       </p:sp>
@@ -11885,7 +11863,7 @@
               <a:buNone/>
             </a:pPr>
             <a:r>
-              <a:rPr lang="en-US" sz="1050" dirty="0">
+              <a:rPr lang="en-US" sz="1100" dirty="0">
                 <a:solidFill>
                   <a:srgbClr val="68667A"/>
                 </a:solidFill>
@@ -11895,7 +11873,7 @@
               </a:rPr>
               <a:t>P4 · Payments &amp; Receipts (0/4)</a:t>
             </a:r>
-            <a:endParaRPr lang="en-US" sz="1050" dirty="0"/>
+            <a:endParaRPr lang="en-US" sz="1100" dirty="0"/>
           </a:p>
         </p:txBody>
       </p:sp>
@@ -11990,7 +11968,7 @@
               <a:buNone/>
             </a:pPr>
             <a:r>
-              <a:rPr lang="en-US" sz="1050" b="1" dirty="0">
+              <a:rPr lang="en-US" sz="1100" b="1" dirty="0">
                 <a:solidFill>
                   <a:srgbClr val="0C7D78"/>
                 </a:solidFill>
@@ -12000,7 +11978,7 @@
               </a:rPr>
               <a:t>ClinicBook · Clinic Dashboard</a:t>
             </a:r>
-            <a:endParaRPr lang="en-US" sz="1050" dirty="0"/>
+            <a:endParaRPr lang="en-US" sz="1100" dirty="0"/>
           </a:p>
         </p:txBody>
       </p:sp>
@@ -12031,7 +12009,7 @@
               <a:buNone/>
             </a:pPr>
             <a:r>
-              <a:rPr lang="en-US" sz="1050" i="1" dirty="0">
+              <a:rPr lang="en-US" sz="1100" i="1" dirty="0">
                 <a:solidFill>
                   <a:srgbClr val="48465C"/>
                 </a:solidFill>
@@ -12041,7 +12019,7 @@
               </a:rPr>
               <a:t>Onboarding and schedules done; reminders in final review.</a:t>
             </a:r>
-            <a:endParaRPr lang="en-US" sz="1050" dirty="0"/>
+            <a:endParaRPr lang="en-US" sz="1100" dirty="0"/>
           </a:p>
         </p:txBody>
       </p:sp>
@@ -12195,7 +12173,7 @@
               <a:buNone/>
             </a:pPr>
             <a:r>
-              <a:rPr lang="en-US" sz="1050" dirty="0">
+              <a:rPr lang="en-US" sz="1100" dirty="0">
                 <a:solidFill>
                   <a:srgbClr val="48465C"/>
                 </a:solidFill>
@@ -12205,7 +12183,7 @@
               </a:rPr>
               <a:t>4 done, 1 open</a:t>
             </a:r>
-            <a:endParaRPr lang="en-US" sz="1050" dirty="0"/>
+            <a:endParaRPr lang="en-US" sz="1100" dirty="0"/>
           </a:p>
         </p:txBody>
       </p:sp>
@@ -12340,7 +12318,7 @@
               <a:buNone/>
             </a:pPr>
             <a:r>
-              <a:rPr lang="en-US" sz="1050" dirty="0">
+              <a:rPr lang="en-US" sz="1100" dirty="0">
                 <a:solidFill>
                   <a:srgbClr val="17153A"/>
                 </a:solidFill>
@@ -12350,7 +12328,7 @@
               </a:rPr>
               <a:t>P1 · Clinic Onboarding (3/3)</a:t>
             </a:r>
-            <a:endParaRPr lang="en-US" sz="1050" dirty="0"/>
+            <a:endParaRPr lang="en-US" sz="1100" dirty="0"/>
           </a:p>
         </p:txBody>
       </p:sp>
@@ -12406,7 +12384,7 @@
               <a:buNone/>
             </a:pPr>
             <a:r>
-              <a:rPr lang="en-US" sz="1050" dirty="0">
+              <a:rPr lang="en-US" sz="1100" dirty="0">
                 <a:solidFill>
                   <a:srgbClr val="17153A"/>
                 </a:solidFill>
@@ -12416,7 +12394,7 @@
               </a:rPr>
               <a:t>P2 · Doctor Schedules (5/5)</a:t>
             </a:r>
-            <a:endParaRPr lang="en-US" sz="1050" dirty="0"/>
+            <a:endParaRPr lang="en-US" sz="1100" dirty="0"/>
           </a:p>
         </p:txBody>
       </p:sp>
@@ -12472,7 +12450,7 @@
               <a:buNone/>
             </a:pPr>
             <a:r>
-              <a:rPr lang="en-US" sz="1050" dirty="0">
+              <a:rPr lang="en-US" sz="1100" dirty="0">
                 <a:solidFill>
                   <a:srgbClr val="17153A"/>
                 </a:solidFill>
@@ -12482,7 +12460,7 @@
               </a:rPr>
               <a:t>P4 · Reminders, in review (5/5)</a:t>
             </a:r>
-            <a:endParaRPr lang="en-US" sz="1050" dirty="0"/>
+            <a:endParaRPr lang="en-US" sz="1100" dirty="0"/>
           </a:p>
         </p:txBody>
       </p:sp>
@@ -12538,7 +12516,7 @@
               <a:buNone/>
             </a:pPr>
             <a:r>
-              <a:rPr lang="en-US" sz="1050" dirty="0">
+              <a:rPr lang="en-US" sz="1100" dirty="0">
                 <a:solidFill>
                   <a:srgbClr val="68667A"/>
                 </a:solidFill>
@@ -12546,9 +12524,9 @@
                 <a:ea typeface="Arial" pitchFamily="34" charset="-122"/>
                 <a:cs typeface="Arial" pitchFamily="34" charset="-120"/>
               </a:rPr>
-              <a:t>P3 · Reports &amp; Exports (0/4)</a:t>
-            </a:r>
-            <a:endParaRPr lang="en-US" sz="1050" dirty="0"/>
+              <a:t>P3 · Reports &amp; Exports (0/3)</a:t>
+            </a:r>
+            <a:endParaRPr lang="en-US" sz="1100" dirty="0"/>
           </a:p>
         </p:txBody>
       </p:sp>
@@ -12643,7 +12621,7 @@
               <a:buNone/>
             </a:pPr>
             <a:r>
-              <a:rPr lang="en-US" sz="1050" b="1" dirty="0">
+              <a:rPr lang="en-US" sz="1100" b="1" dirty="0">
                 <a:solidFill>
                   <a:srgbClr val="866110"/>
                 </a:solidFill>
@@ -12653,7 +12631,7 @@
               </a:rPr>
               <a:t>PulseBoard · Analytics</a:t>
             </a:r>
-            <a:endParaRPr lang="en-US" sz="1050" dirty="0"/>
+            <a:endParaRPr lang="en-US" sz="1100" dirty="0"/>
           </a:p>
         </p:txBody>
       </p:sp>
@@ -12684,7 +12662,7 @@
               <a:buNone/>
             </a:pPr>
             <a:r>
-              <a:rPr lang="en-US" sz="1050" i="1" dirty="0">
+              <a:rPr lang="en-US" sz="1100" i="1" dirty="0">
                 <a:solidFill>
                   <a:srgbClr val="48465C"/>
                 </a:solidFill>
@@ -12692,9 +12670,9 @@
                 <a:ea typeface="Arial" pitchFamily="34" charset="-122"/>
                 <a:cs typeface="Arial" pitchFamily="34" charset="-120"/>
               </a:rPr>
-              <a:t>Data transfer finished; usage tracking being rolled out.</a:t>
-            </a:r>
-            <a:endParaRPr lang="en-US" sz="1050" dirty="0"/>
+              <a:t>Data transfer done; usage tracking rolling out.</a:t>
+            </a:r>
+            <a:endParaRPr lang="en-US" sz="1100" dirty="0"/>
           </a:p>
         </p:txBody>
       </p:sp>
@@ -12873,7 +12851,7 @@
               <a:buNone/>
             </a:pPr>
             <a:r>
-              <a:rPr lang="en-US" sz="1050" dirty="0">
+              <a:rPr lang="en-US" sz="1100" dirty="0">
                 <a:solidFill>
                   <a:srgbClr val="48465C"/>
                 </a:solidFill>
@@ -12883,7 +12861,7 @@
               </a:rPr>
               <a:t>5 done, 1 open</a:t>
             </a:r>
-            <a:endParaRPr lang="en-US" sz="1050" dirty="0"/>
+            <a:endParaRPr lang="en-US" sz="1100" dirty="0"/>
           </a:p>
         </p:txBody>
       </p:sp>
@@ -13018,7 +12996,7 @@
               <a:buNone/>
             </a:pPr>
             <a:r>
-              <a:rPr lang="en-US" sz="1050" dirty="0">
+              <a:rPr lang="en-US" sz="1100" dirty="0">
                 <a:solidFill>
                   <a:srgbClr val="17153A"/>
                 </a:solidFill>
@@ -13028,7 +13006,7 @@
               </a:rPr>
               <a:t>Data transfer to new system</a:t>
             </a:r>
-            <a:endParaRPr lang="en-US" sz="1050" dirty="0"/>
+            <a:endParaRPr lang="en-US" sz="1100" dirty="0"/>
           </a:p>
         </p:txBody>
       </p:sp>
@@ -13084,7 +13062,7 @@
               <a:buNone/>
             </a:pPr>
             <a:r>
-              <a:rPr lang="en-US" sz="1050" dirty="0">
+              <a:rPr lang="en-US" sz="1100" dirty="0">
                 <a:solidFill>
                   <a:srgbClr val="17153A"/>
                 </a:solidFill>
@@ -13094,7 +13072,7 @@
               </a:rPr>
               <a:t>Event plan agreed</a:t>
             </a:r>
-            <a:endParaRPr lang="en-US" sz="1050" dirty="0"/>
+            <a:endParaRPr lang="en-US" sz="1100" dirty="0"/>
           </a:p>
         </p:txBody>
       </p:sp>
@@ -13150,7 +13128,7 @@
               <a:buNone/>
             </a:pPr>
             <a:r>
-              <a:rPr lang="en-US" sz="1050" dirty="0">
+              <a:rPr lang="en-US" sz="1100" dirty="0">
                 <a:solidFill>
                   <a:srgbClr val="17153A"/>
                 </a:solidFill>
@@ -13160,7 +13138,7 @@
               </a:rPr>
               <a:t>Usage tracking rollout</a:t>
             </a:r>
-            <a:endParaRPr lang="en-US" sz="1050" dirty="0"/>
+            <a:endParaRPr lang="en-US" sz="1100" dirty="0"/>
           </a:p>
         </p:txBody>
       </p:sp>
@@ -13216,7 +13194,7 @@
               <a:buNone/>
             </a:pPr>
             <a:r>
-              <a:rPr lang="en-US" sz="1050" dirty="0">
+              <a:rPr lang="en-US" sz="1100" dirty="0">
                 <a:solidFill>
                   <a:srgbClr val="17153A"/>
                 </a:solidFill>
@@ -13224,9 +13202,9 @@
                 <a:ea typeface="Arial" pitchFamily="34" charset="-122"/>
                 <a:cs typeface="Arial" pitchFamily="34" charset="-120"/>
               </a:rPr>
-              <a:t>Code reviews · 3 features</a:t>
-            </a:r>
-            <a:endParaRPr lang="en-US" sz="1050" dirty="0"/>
+              <a:t>Code reviews, 3 features</a:t>
+            </a:r>
+            <a:endParaRPr lang="en-US" sz="1100" dirty="0"/>
           </a:p>
         </p:txBody>
       </p:sp>
@@ -13255,7 +13233,7 @@
               <a:buNone/>
             </a:pPr>
             <a:r>
-              <a:rPr lang="en-US" sz="1000" i="1" dirty="0">
+              <a:rPr lang="en-US" sz="1100" i="1" dirty="0">
                 <a:solidFill>
                   <a:srgbClr val="68667A"/>
                 </a:solidFill>
@@ -13265,7 +13243,7 @@
               </a:rPr>
               <a:t>Done/Open = planned tasks this week; work in review stays open until approved.</a:t>
             </a:r>
-            <a:endParaRPr lang="en-US" sz="1000" dirty="0"/>
+            <a:endParaRPr lang="en-US" sz="1100" dirty="0"/>
           </a:p>
         </p:txBody>
       </p:sp>
@@ -13429,7 +13407,7 @@
               <a:buNone/>
             </a:pPr>
             <a:r>
-              <a:rPr lang="en-US" sz="900" dirty="0">
+              <a:rPr lang="en-US" sz="1100" dirty="0">
                 <a:solidFill>
                   <a:srgbClr val="68667A"/>
                 </a:solidFill>
@@ -13437,15 +13415,15 @@
                 <a:ea typeface="Arial" pitchFamily="34" charset="-122"/>
                 <a:cs typeface="Arial" pitchFamily="34" charset="-120"/>
               </a:rPr>
-              <a:t>Acme Digital Co., Ltd.  ·  October 9, 2026</a:t>
-            </a:r>
-            <a:endParaRPr lang="en-US" sz="900" dirty="0"/>
+              <a:t>October 9, 2026</a:t>
+            </a:r>
+            <a:endParaRPr lang="en-US" sz="1100" dirty="0"/>
           </a:p>
         </p:txBody>
       </p:sp>
       <p:pic>
         <p:nvPicPr>
-          <p:cNvPr id="6" name="Image 0" descr="/sessions/beautiful-vigilant-darwin/tmp/showship-deck-xNahHf/paper_mark.png">    </p:cNvPr>
+          <p:cNvPr id="6" name="Image 0" descr="/var/folders/lw/rmylcyvd5rjfxk9g1z9rrm8w0000gq/T/showship-deck-L0Xly7/paper_mark.png">    </p:cNvPr>
           <p:cNvPicPr>
             <a:picLocks noChangeAspect="1"/>
           </p:cNvPicPr>
@@ -13492,7 +13470,7 @@
               <a:buNone/>
             </a:pPr>
             <a:r>
-              <a:rPr lang="en-US" sz="900" dirty="0">
+              <a:rPr lang="en-US" sz="1100" dirty="0">
                 <a:solidFill>
                   <a:srgbClr val="68667A"/>
                 </a:solidFill>
@@ -13506,7 +13484,7 @@
               <a:buNone/>
             </a:pPr>
             <a:r>
-              <a:rPr lang="en-US" sz="900" b="1" dirty="0">
+              <a:rPr lang="en-US" sz="1100" b="1" dirty="0">
                 <a:solidFill>
                   <a:srgbClr val="17153A"/>
                 </a:solidFill>
@@ -13516,7 +13494,7 @@
               </a:rPr>
               <a:t>Showship</a:t>
             </a:r>
-            <a:endParaRPr lang="en-US" sz="900" dirty="0"/>
+            <a:endParaRPr lang="en-US" sz="1100" dirty="0"/>
           </a:p>
         </p:txBody>
       </p:sp>
@@ -13545,7 +13523,7 @@
               <a:buNone/>
             </a:pPr>
             <a:r>
-              <a:rPr lang="en-US" sz="900" b="1" dirty="0">
+              <a:rPr lang="en-US" sz="1100" b="1" dirty="0">
                 <a:solidFill>
                   <a:srgbClr val="17153A"/>
                 </a:solidFill>
@@ -13555,7 +13533,7 @@
               </a:rPr>
               <a:t>9</a:t>
             </a:r>
-            <a:endParaRPr lang="en-US" sz="900" dirty="0"/>
+            <a:endParaRPr lang="en-US" sz="1100" dirty="0"/>
           </a:p>
         </p:txBody>
       </p:sp>
@@ -13584,7 +13562,7 @@
               <a:buNone/>
             </a:pPr>
             <a:r>
-              <a:rPr lang="en-US" sz="5400" b="1" dirty="0">
+              <a:rPr lang="en-US" sz="4400" b="1" dirty="0">
                 <a:solidFill>
                   <a:srgbClr val="6C4CF5"/>
                 </a:solidFill>
@@ -13594,7 +13572,7 @@
               </a:rPr>
               <a:t>3</a:t>
             </a:r>
-            <a:endParaRPr lang="en-US" sz="5400" dirty="0"/>
+            <a:endParaRPr lang="en-US" sz="4400" dirty="0"/>
           </a:p>
         </p:txBody>
       </p:sp>
@@ -13685,7 +13663,7 @@
               <a:buNone/>
             </a:pPr>
             <a:r>
-              <a:rPr lang="en-US" sz="3600" b="1" dirty="0">
+              <a:rPr lang="en-US" sz="3200" b="1" dirty="0">
                 <a:solidFill>
                   <a:srgbClr val="17153A"/>
                 </a:solidFill>
@@ -13695,7 +13673,7 @@
               </a:rPr>
               <a:t>2</a:t>
             </a:r>
-            <a:endParaRPr lang="en-US" sz="3600" dirty="0"/>
+            <a:endParaRPr lang="en-US" sz="3200" dirty="0"/>
           </a:p>
         </p:txBody>
       </p:sp>
@@ -13786,7 +13764,7 @@
               <a:buNone/>
             </a:pPr>
             <a:r>
-              <a:rPr lang="en-US" sz="3600" b="1" dirty="0">
+              <a:rPr lang="en-US" sz="3200" b="1" dirty="0">
                 <a:solidFill>
                   <a:srgbClr val="17153A"/>
                 </a:solidFill>
@@ -13796,7 +13774,7 @@
               </a:rPr>
               <a:t>7</a:t>
             </a:r>
-            <a:endParaRPr lang="en-US" sz="3600" dirty="0"/>
+            <a:endParaRPr lang="en-US" sz="3200" dirty="0"/>
           </a:p>
         </p:txBody>
       </p:sp>
@@ -13880,7 +13858,7 @@
               <a:buNone/>
             </a:pPr>
             <a:r>
-              <a:rPr lang="en-US" sz="1000" i="1" dirty="0">
+              <a:rPr lang="en-US" sz="1100" i="1" dirty="0">
                 <a:solidFill>
                   <a:srgbClr val="68667A"/>
                 </a:solidFill>
@@ -13890,7 +13868,7 @@
               </a:rPr>
               <a:t>Source: GitHub activity this week.</a:t>
             </a:r>
-            <a:endParaRPr lang="en-US" sz="1000" dirty="0"/>
+            <a:endParaRPr lang="en-US" sz="1100" dirty="0"/>
           </a:p>
         </p:txBody>
       </p:sp>

</xml_diff>